<commit_message>
docs: finalize slide text & pptx with Idea ID 21121 and RPL title
</commit_message>
<xml_diff>
--- a/SIH_PPT_AIZENIX_176704.pptx
+++ b/SIH_PPT_AIZENIX_176704.pptx
@@ -3172,9 +3172,9 @@
           <a:p>
             <a:pPr>
               <a:spcAft>
-                <a:spcPts val="1000"/>
+                <a:spcPts val="600"/>
               </a:spcAft>
-              <a:defRPr sz="4000" b="1">
+              <a:defRPr sz="3600" b="1">
                 <a:solidFill>
                   <a:srgbClr val="FFFFFF"/>
                 </a:solidFill>
@@ -3187,16 +3187,31 @@
           <a:p>
             <a:pPr>
               <a:spcAft>
-                <a:spcPts val="2800"/>
+                <a:spcPts val="400"/>
               </a:spcAft>
-              <a:defRPr sz="1600">
+              <a:defRPr sz="1700" b="1">
+                <a:solidFill>
+                  <a:srgbClr val="FED7AA"/>
+                </a:solidFill>
+              </a:defRPr>
+            </a:pPr>
+            <a:r>
+              <a:t>AI-Assisted Skill Assessment &amp; Competency Calibration Platform</a:t>
+            </a:r>
+          </a:p>
+          <a:p>
+            <a:pPr>
+              <a:spcAft>
+                <a:spcPts val="1800"/>
+              </a:spcAft>
+              <a:defRPr sz="1300">
                 <a:solidFill>
                   <a:srgbClr val="E0F2FE"/>
                 </a:solidFill>
               </a:defRPr>
             </a:pPr>
             <a:r>
-              <a:t>Adaptive Competency Diagnostic &amp; Automated Capacity Building Platform for Public Sector &amp; Higher Education</a:t>
+              <a:t>Adaptive Competency Diagnostic &amp; Automated Capacity Building Platform for Public Sector and RPL Framework</a:t>
             </a:r>
           </a:p>
         </p:txBody>
@@ -3209,8 +3224,8 @@
         </p:nvSpPr>
         <p:spPr>
           <a:xfrm>
-            <a:off x="914400" y="3840480"/>
-            <a:ext cx="10362895" cy="2011680"/>
+            <a:off x="914400" y="3749039"/>
+            <a:ext cx="10362895" cy="2194560"/>
           </a:xfrm>
           <a:prstGeom prst="roundRect">
             <a:avLst/>
@@ -3239,36 +3254,36 @@
           </a:fontRef>
         </p:style>
         <p:txBody>
-          <a:bodyPr rtlCol="0" anchor="ctr" wrap="square" lIns="365760" tIns="274320"/>
+          <a:bodyPr rtlCol="0" anchor="ctr" wrap="square" lIns="365760" tIns="228600"/>
           <a:lstStyle/>
           <a:p>
             <a:pPr algn="ctr">
               <a:spcAft>
-                <a:spcPts val="800"/>
+                <a:spcPts val="600"/>
+              </a:spcAft>
+              <a:defRPr sz="1200" b="1">
+                <a:solidFill>
+                  <a:srgbClr val="FFFFFF"/>
+                </a:solidFill>
+              </a:defRPr>
+            </a:pPr>
+            <a:r>
+              <a:t>• Theme: Smart Education   |   • Category: Software   |   • Target Ecosystem: Mission Karmayogi (iGOT) &amp; RPL</a:t>
+            </a:r>
+          </a:p>
+          <a:p>
+            <a:pPr>
+              <a:spcAft>
+                <a:spcPts val="600"/>
               </a:spcAft>
               <a:defRPr sz="1300" b="1">
                 <a:solidFill>
-                  <a:srgbClr val="FFFFFF"/>
-                </a:solidFill>
-              </a:defRPr>
-            </a:pPr>
-            <a:r>
-              <a:t>• Theme: Smart Education  |  • Category: Software  |  • Target Ecosystem: Mission Karmayogi (iGOT Bharat) &amp; MoSPI</a:t>
-            </a:r>
-          </a:p>
-          <a:p>
-            <a:pPr>
-              <a:spcAft>
-                <a:spcPts val="800"/>
-              </a:spcAft>
-              <a:defRPr sz="1300" b="1">
-                <a:solidFill>
                   <a:srgbClr val="FED7AA"/>
                 </a:solidFill>
               </a:defRPr>
             </a:pPr>
             <a:r>
-              <a:t>• Team Name: AIZENIX   |  • Team ID: 176704   |  • Idea / PS ID: 21121</a:t>
+              <a:t>• Team Name: AIZENIX       |   • Team ID: 176704      |   • Idea / PS ID: 21121</a:t>
             </a:r>
           </a:p>
           <a:p>
@@ -3280,7 +3295,7 @@
               </a:defRPr>
             </a:pPr>
             <a:r>
-              <a:t>• Live Prototype: https://statskill-ai-five.vercel.app  |  • GitHub: https://github.com/iamwarriorofmyuniverse-coder/statskill-ai</a:t>
+              <a:t>• Live Prototype: https://statskill-ai-five.vercel.app   |   • GitHub: https://github.com/iamwarriorofmyuniverse-coder/statskill-ai</a:t>
             </a:r>
           </a:p>
         </p:txBody>

</xml_diff>